<commit_message>
Add evaluation report, architecture diagram; remove Parquet references
- Add EVALUATION_REPORT.md with metrics, feature importance, drift, and leakage prevention
- Add architecture diagram to README.md
- Replace all Parquet references with CSV across docs, build scripts, and slides
- Remove pyarrow from requirements.txt
- Regenerate DOCUMENTATION.docx, PITCH_DECK.pptx, ONE_PAGE_SUMMARY.pptx

Co-Authored-By: Claude Opus 4.6 <noreply@anthropic.com>
</commit_message>
<xml_diff>
--- a/ONE_PAGE_SUMMARY.pptx
+++ b/ONE_PAGE_SUMMARY.pptx
@@ -1367,7 +1367,7 @@
                 </a:solidFill>
               </a:rPr>
               <a:t>Feature Store
-(Parquet)</a:t>
+(CSV)</a:t>
             </a:r>
             <a:endParaRPr lang="en-US" sz="950" dirty="0"/>
           </a:p>
@@ -1685,7 +1685,7 @@
                 </a:solidFill>
                 <a:latin typeface="Calibri"/>
               </a:rPr>
-              <a:t>Data store: Apache Parquet feature store + CSV lineage metadata</a:t>
+              <a:t>Data store: CSV feature store + CSV lineage metadata</a:t>
             </a:r>
           </a:p>
           <a:p>
@@ -1809,7 +1809,7 @@
                 </a:solidFill>
                 <a:latin typeface="Calibri"/>
               </a:rPr>
-              <a:t>Synthetic ERP data (2,700 daily records, 92 POs, 5 SKUs, 4 suppliers) flows into a feature engineering pipeline that computes 15 structured features. In parallel, 58 supplier notes are sent to GPT-4o, which extracts early_delay_flag, expected_delay_days, and delay_reason into structured JSON. Both feature sets merge in a Parquet feature store with lineage tracking and a 24h freshness SLA. Two identical XGBoost models are trained — Baseline (ERP only) vs Enhanced (ERP + notes) — on a chronological 80/20 split. The enhanced model reduces MAPE from 25.01% to 23.36% (-6.6%), with early_delay_flag ranking as the #1 most important feature. The key design decision: excluding delay_reason from the model despite extracting it — PSI of 1.06 confirmed it drifts too heavily for stable prediction.</a:t>
+              <a:t>Synthetic ERP data (2,700 daily records, 92 POs, 5 SKUs, 4 suppliers) flows into a feature engineering pipeline that computes 15 structured features. In parallel, 58 supplier notes are sent to GPT-4o, which extracts early_delay_flag, expected_delay_days, and delay_reason into structured JSON. Both feature sets merge in a CSV feature store with lineage tracking and a 24h freshness SLA. Two identical XGBoost models are trained — Baseline (ERP only) vs Enhanced (ERP + notes) — on a chronological 80/20 split. The enhanced model reduces MAPE from 25.01% to 23.36% (-6.6%), with early_delay_flag ranking as the #1 most important feature. The key design decision: excluding delay_reason from the model despite extracting it — PSI of 1.06 confirmed it drifts too heavily for stable prediction.</a:t>
             </a:r>
             <a:endParaRPr lang="en-US" sz="1100" dirty="0"/>
           </a:p>

</xml_diff>

<commit_message>
Update one-page summary: Track 1, full name, add MAPE and freshness SLA
- Track 1, Team: Damini Thandele, Date: 10 Oct 2026
- Remove CSV mention from Feature Store box
- Add Freshness SLA to pipeline flow
- Add MAPE metric to eval/monitoring line
- Replace Azure next step with streaming extraction and auto-retraining

Co-Authored-By: Claude Opus 4.6 <noreply@anthropic.com>
</commit_message>
<xml_diff>
--- a/ONE_PAGE_SUMMARY.pptx
+++ b/ONE_PAGE_SUMMARY.pptx
@@ -1069,7 +1069,7 @@
                   <a:srgbClr val="F3E7DF"/>
                 </a:solidFill>
               </a:rPr>
-              <a:t>Track: 2   ·   Domain: Supply Chain / Retail   ·   Team: Damie   ·   Date: 29 Sep 2026</a:t>
+              <a:t>Track: 1   ·   Domain: Supply Chain / Retail   ·   Team: Damini Thandele   ·   Date: 10 Oct 2026</a:t>
             </a:r>
             <a:endParaRPr lang="en-US" sz="950" dirty="0">
               <a:latin typeface="Calibri"/>
@@ -1366,8 +1366,7 @@
                   <a:srgbClr val="FFFFFF"/>
                 </a:solidFill>
               </a:rPr>
-              <a:t>Feature Store
-(CSV)</a:t>
+              <a:t>Feature Store</a:t>
             </a:r>
             <a:endParaRPr lang="en-US" sz="950" dirty="0"/>
           </a:p>
@@ -1464,8 +1463,8 @@
                   <a:srgbClr val="FFFFFF"/>
                 </a:solidFill>
               </a:rPr>
-              <a:t>PSI Drift
-Monitoring</a:t>
+              <a:t>Freshness SLA
++ PSI Drift</a:t>
             </a:r>
             <a:endParaRPr lang="en-US" sz="950" dirty="0"/>
           </a:p>
@@ -1685,7 +1684,7 @@
                 </a:solidFill>
                 <a:latin typeface="Calibri"/>
               </a:rPr>
-              <a:t>Data store: CSV feature store + CSV lineage metadata</a:t>
+              <a:t>Data store: Feature store with lineage metadata</a:t>
             </a:r>
           </a:p>
           <a:p>
@@ -1696,7 +1695,7 @@
                 </a:solidFill>
                 <a:latin typeface="Calibri"/>
               </a:rPr>
-              <a:t>Eval/monitoring: PSI/CSI drift detection, 24h freshness SLA</a:t>
+              <a:t>Eval/monitoring: MAPE (25.01% → 23.36%), PSI/CSI drift detection, 24h freshness SLA</a:t>
             </a:r>
           </a:p>
           <a:p>
@@ -1809,7 +1808,7 @@
                 </a:solidFill>
                 <a:latin typeface="Calibri"/>
               </a:rPr>
-              <a:t>Synthetic ERP data (2,700 daily records, 92 POs, 5 SKUs, 4 suppliers) flows into a feature engineering pipeline that computes 15 structured features. In parallel, 58 supplier notes are sent to GPT-4o, which extracts early_delay_flag, expected_delay_days, and delay_reason into structured JSON. Both feature sets merge in a CSV feature store with lineage tracking and a 24h freshness SLA. Two identical XGBoost models are trained — Baseline (ERP only) vs Enhanced (ERP + notes) — on a chronological 80/20 split. The enhanced model reduces MAPE from 25.01% to 23.36% (-6.6%), with early_delay_flag ranking as the #1 most important feature. The key design decision: excluding delay_reason from the model despite extracting it — PSI of 1.06 confirmed it drifts too heavily for stable prediction.</a:t>
+              <a:t>Synthetic ERP data (2,700 daily records, 92 POs, 5 SKUs, 4 suppliers) flows into a feature engineering pipeline that computes 15 structured features. In parallel, 58 supplier notes are sent to GPT-4o, which extracts early_delay_flag, expected_delay_days, and delay_reason into structured JSON. Both feature sets merge in a feature store with lineage tracking and a 24h freshness SLA. Two identical XGBoost models are trained — Baseline (ERP only) vs Enhanced (ERP + notes) — on a chronological 80/20 split. The enhanced model reduces MAPE from 25.01% to 23.36% (-6.6%), with early_delay_flag ranking as the #1 most important feature. The key design decision: excluding delay_reason from the model despite extracting it — PSI of 1.06 confirmed it drifts too heavily for stable prediction.</a:t>
             </a:r>
             <a:endParaRPr lang="en-US" sz="1100" dirty="0"/>
           </a:p>
@@ -3033,7 +3032,7 @@
                 </a:solidFill>
                 <a:latin typeface="Calibri"/>
               </a:rPr>
-              <a:t>Next step: Hyperparameter tuning (Optuna) + Azure deployment (Blob Storage + Azure ML) for production-ready pipeline</a:t>
+              <a:t>Next step: Hyperparameter tuning (Optuna), real-time streaming extraction, automated retraining on PSI drift alerts</a:t>
             </a:r>
           </a:p>
         </p:txBody>

</xml_diff>